<commit_message>
Add executive brief; fix 21-teams claim to designed-to-scale across artifacts
Co-Authored-By: Claude Fable 5 <noreply@anthropic.com>
Claude-Session: https://claude.ai/code/session_01Pq1xCFkgvTtEpdHVPbwQEw
</commit_message>
<xml_diff>
--- a/showcase/Proof-to-Possibility-Checkpoint.pptx
+++ b/showcase/Proof-to-Possibility-Checkpoint.pptx
@@ -3154,7 +3154,7 @@
                 <a:ea typeface="Calibri" pitchFamily="34" charset="-122"/>
                 <a:cs typeface="Calibri" pitchFamily="34" charset="-120"/>
               </a:rPr>
-              <a:t>product teams running the DRIPS continuous-improvement loop</a:t>
+              <a:t>product teams in the WCS footprint the DRIPS loop is designed to scale across</a:t>
             </a:r>
             <a:endParaRPr lang="en-US" sz="1200" dirty="0"/>
           </a:p>
@@ -4843,7 +4843,7 @@
                 <a:ea typeface="Calibri" pitchFamily="34" charset="-122"/>
                 <a:cs typeface="Calibri" pitchFamily="34" charset="-120"/>
               </a:rPr>
-              <a:t>MRTS, Sprint 70, DRIPS across 21 teams — the numbers I'm leading with. Anything stronger I should surface?</a:t>
+              <a:t>MRTS, Sprint 70, the DRIPS scale-out design — the evidence I'm leading with. Anything stronger I should surface?</a:t>
             </a:r>
             <a:endParaRPr lang="en-US" sz="1350" dirty="0"/>
           </a:p>

</xml_diff>